<commit_message>
Add leadership safety commitment ratings
</commit_message>
<xml_diff>
--- a/docs/platform-flow-map/safety360-platform-flow-map.pptx
+++ b/docs/platform-flow-map/safety360-platform-flow-map.pptx
@@ -3858,31 +3858,6 @@
         </p:nvSpPr>
         <p:spPr>
           <a:xfrm>
-            <a:off x="10844784" y="4041648"/>
-            <a:ext cx="-7141464" cy="-1033272"/>
-          </a:xfrm>
-          <a:prstGeom prst="line">
-            <a:avLst/>
-          </a:prstGeom>
-          <a:noFill/>
-          <a:ln w="12700">
-            <a:solidFill>
-              <a:srgbClr val="2E7D32"/>
-            </a:solidFill>
-            <a:prstDash val="solid"/>
-            <a:headEnd type="none"/>
-            <a:tailEnd type="triangle"/>
-          </a:ln>
-        </p:spPr>
-      </p:sp>
-      <p:sp>
-        <p:nvSpPr>
-          <p:cNvPr id="71" name="Shape 69"/>
-          <p:cNvSpPr/>
-          <p:nvPr/>
-        </p:nvSpPr>
-        <p:spPr>
-          <a:xfrm>
             <a:off x="859536" y="2432304"/>
             <a:ext cx="0" cy="310896"/>
           </a:xfrm>
@@ -3900,7 +3875,7 @@
       </p:sp>
       <p:sp>
         <p:nvSpPr>
-          <p:cNvPr id="72" name="Shape 70"/>
+          <p:cNvPr id="71" name="Shape 69"/>
           <p:cNvSpPr/>
           <p:nvPr/>
         </p:nvSpPr>
@@ -3925,14 +3900,60 @@
       </p:sp>
       <p:sp>
         <p:nvSpPr>
+          <p:cNvPr id="72" name="Shape 70"/>
+          <p:cNvSpPr/>
+          <p:nvPr/>
+        </p:nvSpPr>
+        <p:spPr>
+          <a:xfrm>
+            <a:off x="10844784" y="4882896"/>
+            <a:ext cx="0" cy="347472"/>
+          </a:xfrm>
+          <a:prstGeom prst="line">
+            <a:avLst/>
+          </a:prstGeom>
+          <a:noFill/>
+          <a:ln w="12700">
+            <a:solidFill>
+              <a:srgbClr val="2E7D32"/>
+            </a:solidFill>
+            <a:prstDash val="solid"/>
+          </a:ln>
+        </p:spPr>
+      </p:sp>
+      <p:sp>
+        <p:nvSpPr>
           <p:cNvPr id="73" name="Shape 71"/>
           <p:cNvSpPr/>
           <p:nvPr/>
         </p:nvSpPr>
         <p:spPr>
           <a:xfrm>
-            <a:off x="3456432" y="3008376"/>
-            <a:ext cx="0" cy="2221992"/>
+            <a:off x="10844784" y="5230368"/>
+            <a:ext cx="-7388352" cy="0"/>
+          </a:xfrm>
+          <a:prstGeom prst="line">
+            <a:avLst/>
+          </a:prstGeom>
+          <a:noFill/>
+          <a:ln w="12700">
+            <a:solidFill>
+              <a:srgbClr val="9AA9B4"/>
+            </a:solidFill>
+            <a:prstDash val="solid"/>
+          </a:ln>
+        </p:spPr>
+      </p:sp>
+      <p:sp>
+        <p:nvSpPr>
+          <p:cNvPr id="74" name="Shape 72"/>
+          <p:cNvSpPr/>
+          <p:nvPr/>
+        </p:nvSpPr>
+        <p:spPr>
+          <a:xfrm>
+            <a:off x="3456432" y="5230368"/>
+            <a:ext cx="0" cy="-2221992"/>
           </a:xfrm>
           <a:prstGeom prst="line">
             <a:avLst/>
@@ -3950,55 +3971,7 @@
       </p:sp>
       <p:sp>
         <p:nvSpPr>
-          <p:cNvPr id="74" name="Shape 72"/>
-          <p:cNvSpPr/>
-          <p:nvPr/>
-        </p:nvSpPr>
-        <p:spPr>
-          <a:xfrm>
-            <a:off x="3456432" y="5230368"/>
-            <a:ext cx="7388352" cy="0"/>
-          </a:xfrm>
-          <a:prstGeom prst="line">
-            <a:avLst/>
-          </a:prstGeom>
-          <a:noFill/>
-          <a:ln w="12700">
-            <a:solidFill>
-              <a:srgbClr val="9AA9B4"/>
-            </a:solidFill>
-            <a:prstDash val="solid"/>
-          </a:ln>
-        </p:spPr>
-      </p:sp>
-      <p:sp>
-        <p:nvSpPr>
           <p:cNvPr id="75" name="Shape 73"/>
-          <p:cNvSpPr/>
-          <p:nvPr/>
-        </p:nvSpPr>
-        <p:spPr>
-          <a:xfrm>
-            <a:off x="10844784" y="5230368"/>
-            <a:ext cx="0" cy="-347472"/>
-          </a:xfrm>
-          <a:prstGeom prst="line">
-            <a:avLst/>
-          </a:prstGeom>
-          <a:noFill/>
-          <a:ln w="12700">
-            <a:solidFill>
-              <a:srgbClr val="2E7D32"/>
-            </a:solidFill>
-            <a:prstDash val="solid"/>
-            <a:headEnd type="none"/>
-            <a:tailEnd type="triangle"/>
-          </a:ln>
-        </p:spPr>
-      </p:sp>
-      <p:sp>
-        <p:nvSpPr>
-          <p:cNvPr id="76" name="Shape 74"/>
           <p:cNvSpPr/>
           <p:nvPr/>
         </p:nvSpPr>
@@ -4025,7 +3998,7 @@
       </p:sp>
       <p:sp>
         <p:nvSpPr>
-          <p:cNvPr id="77" name="Text 75"/>
+          <p:cNvPr id="76" name="Text 74"/>
           <p:cNvSpPr/>
           <p:nvPr/>
         </p:nvSpPr>
@@ -4066,7 +4039,7 @@
       </p:sp>
       <p:sp>
         <p:nvSpPr>
-          <p:cNvPr id="78" name="Text 76"/>
+          <p:cNvPr id="77" name="Text 75"/>
           <p:cNvSpPr/>
           <p:nvPr/>
         </p:nvSpPr>
@@ -4107,7 +4080,7 @@
       </p:sp>
       <p:sp>
         <p:nvSpPr>
-          <p:cNvPr id="79" name="Text 77"/>
+          <p:cNvPr id="78" name="Text 76"/>
           <p:cNvSpPr/>
           <p:nvPr/>
         </p:nvSpPr>

</xml_diff>